<commit_message>
Add Nextflow setup slide to overview deck
Adds a 'How it runs' slide: samplesheet -> channels -> per-caller Singularity
processes -> post-processing, with repo layout, profiles and reproducibility.

Co-Authored-By: Claude Opus 4.8 <noreply@anthropic.com>
Claude-Session: https://claude.ai/code/session_01CUMK8XHAXRyQStNzgjbr5K
</commit_message>
<xml_diff>
--- a/pgx_pipeline_overview.pptx
+++ b/pgx_pipeline_overview.pptx
@@ -15,9 +15,10 @@
     <p:sldId id="263" r:id="rId9"/>
     <p:sldId id="264" r:id="rId10"/>
     <p:sldId id="265" r:id="rId11"/>
+    <p:sldId id="266" r:id="rId12"/>
   </p:sldIdLst>
   <p:notesMasterIdLst>
-    <p:notesMasterId r:id="rId12"/>
+    <p:notesMasterId r:id="rId13"/>
   </p:notesMasterIdLst>
   <p:sldSz cx="12191695" cy="6858000"/>
   <p:notesSz cx="6858000" cy="12191695"/>
@@ -599,7 +600,7 @@
           <a:p>
             <a:r>
               <a:rPr lang="en-US" dirty="0"/>
-              <a:t>Close: the deliverable is a consensus plus a transparent record of where tools disagree.</a:t>
+              <a:t>Technical scheme: samplesheet to channels to per-caller Singularity processes to post-processing. Config, profiles and reproducibility features below.</a:t>
             </a:r>
             <a:endParaRPr lang="en-US" dirty="0"/>
           </a:p>
@@ -623,6 +624,94 @@
             <a:fld id="{F7021451-1387-4CA6-816F-3879F97B5CBC}" type="slidenum">
               <a:rPr lang="en-US"/>
               <a:t>10</a:t>
+            </a:fld>
+            <a:endParaRPr lang="en-US"/>
+          </a:p>
+        </p:txBody>
+      </p:sp>
+    </p:spTree>
+    <p:extLst>
+      <p:ext uri="{BB962C8B-B14F-4D97-AF65-F5344CB8AC3E}">
+        <p14:creationId xmlns:p14="http://schemas.microsoft.com/office/powerpoint/2010/main" val="1024086991"/>
+      </p:ext>
+    </p:extLst>
+  </p:cSld>
+  <p:clrMapOvr>
+    <a:masterClrMapping/>
+  </p:clrMapOvr>
+</p:notes>
+</file>
+
+<file path=ppt/notesSlides/notesSlide11.xml><?xml version="1.0" encoding="utf-8"?>
+<p:notes xmlns:a="http://schemas.openxmlformats.org/drawingml/2006/main" xmlns:r="http://schemas.openxmlformats.org/officeDocument/2006/relationships" xmlns:p="http://schemas.openxmlformats.org/presentationml/2006/main">
+  <p:cSld>
+    <p:spTree>
+      <p:nvGrpSpPr>
+        <p:cNvPr id="1" name=""/>
+        <p:cNvGrpSpPr/>
+        <p:nvPr/>
+      </p:nvGrpSpPr>
+      <p:grpSpPr>
+        <a:xfrm>
+          <a:off x="0" y="0"/>
+          <a:ext cx="0" cy="0"/>
+          <a:chOff x="0" y="0"/>
+          <a:chExt cx="0" cy="0"/>
+        </a:xfrm>
+      </p:grpSpPr>
+      <p:sp>
+        <p:nvSpPr>
+          <p:cNvPr id="2" name="Slide Image Placeholder 1"/>
+          <p:cNvSpPr>
+            <a:spLocks noGrp="1" noRot="1" noChangeAspect="1"/>
+          </p:cNvSpPr>
+          <p:nvPr>
+            <p:ph type="sldImg"/>
+          </p:nvPr>
+        </p:nvSpPr>
+        <p:spPr/>
+      </p:sp>
+      <p:sp>
+        <p:nvSpPr>
+          <p:cNvPr id="3" name="Notes Placeholder 2"/>
+          <p:cNvSpPr>
+            <a:spLocks noGrp="1"/>
+          </p:cNvSpPr>
+          <p:nvPr>
+            <p:ph type="body" idx="1"/>
+          </p:nvPr>
+        </p:nvSpPr>
+        <p:spPr/>
+        <p:txBody>
+          <a:bodyPr/>
+          <a:lstStyle/>
+          <a:p>
+            <a:r>
+              <a:rPr lang="en-US" dirty="0"/>
+              <a:t>Close: the deliverable is a consensus plus a transparent record of where tools disagree.</a:t>
+            </a:r>
+            <a:endParaRPr lang="en-US" dirty="0"/>
+          </a:p>
+        </p:txBody>
+      </p:sp>
+      <p:sp>
+        <p:nvSpPr>
+          <p:cNvPr id="4" name="Slide Number Placeholder 3"/>
+          <p:cNvSpPr>
+            <a:spLocks noGrp="1"/>
+          </p:cNvSpPr>
+          <p:nvPr>
+            <p:ph type="sldNum" sz="quarter" idx="10"/>
+          </p:nvPr>
+        </p:nvSpPr>
+        <p:spPr/>
+        <p:txBody>
+          <a:bodyPr/>
+          <a:lstStyle/>
+          <a:p>
+            <a:fld id="{F7021451-1387-4CA6-816F-3879F97B5CBC}" type="slidenum">
+              <a:rPr lang="en-US"/>
+              <a:t>11</a:t>
             </a:fld>
             <a:endParaRPr lang="en-US"/>
           </a:p>
@@ -2403,6 +2492,1328 @@
 <file path=ppt/slides/slide10.xml><?xml version="1.0" encoding="utf-8"?>
 <p:sld xmlns:a="http://schemas.openxmlformats.org/drawingml/2006/main" xmlns:r="http://schemas.openxmlformats.org/officeDocument/2006/relationships" xmlns:p="http://schemas.openxmlformats.org/presentationml/2006/main">
   <p:cSld name="Slide 10">
+    <p:spTree>
+      <p:nvGrpSpPr>
+        <p:cNvPr id="1" name=""/>
+        <p:cNvGrpSpPr/>
+        <p:nvPr/>
+      </p:nvGrpSpPr>
+      <p:grpSpPr>
+        <a:xfrm>
+          <a:off x="0" y="0"/>
+          <a:ext cx="0" cy="0"/>
+          <a:chOff x="0" y="0"/>
+          <a:chExt cx="0" cy="0"/>
+        </a:xfrm>
+      </p:grpSpPr>
+      <p:sp>
+        <p:nvSpPr>
+          <p:cNvPr id="2" name="Text 0"/>
+          <p:cNvSpPr/>
+          <p:nvPr>
+            <p:ph idx="100" type="title" hasCustomPrompt="1"/>
+          </p:nvPr>
+        </p:nvSpPr>
+        <p:spPr>
+          <a:xfrm>
+            <a:off x="548640" y="384048"/>
+            <a:ext cx="11064240" cy="822960"/>
+          </a:xfrm>
+          <a:prstGeom prst="rect">
+            <a:avLst/>
+          </a:prstGeom>
+          <a:noFill/>
+          <a:ln/>
+        </p:spPr>
+        <p:txBody>
+          <a:bodyPr wrap="square" rtlCol="0" anchor="ctr"/>
+          <a:lstStyle/>
+          <a:p>
+            <a:pPr algn="l" indent="0" marL="0">
+              <a:buNone/>
+            </a:pPr>
+            <a:r>
+              <a:rPr lang="en-US" sz="3000" b="1" dirty="0">
+                <a:solidFill>
+                  <a:srgbClr val="12243A"/>
+                </a:solidFill>
+                <a:latin typeface="Cambria" pitchFamily="34" charset="0"/>
+                <a:ea typeface="Cambria" pitchFamily="34" charset="-122"/>
+                <a:cs typeface="Cambria" pitchFamily="34" charset="-120"/>
+              </a:rPr>
+              <a:t>How it runs — Nextflow + Singularity</a:t>
+            </a:r>
+            <a:endParaRPr lang="en-US" sz="3000" dirty="0"/>
+          </a:p>
+        </p:txBody>
+      </p:sp>
+      <p:sp>
+        <p:nvSpPr>
+          <p:cNvPr id="3" name="stg-samplesheet.csv"/>
+          <p:cNvSpPr/>
+          <p:nvPr/>
+        </p:nvSpPr>
+        <p:spPr>
+          <a:xfrm>
+            <a:off x="548640" y="1463040"/>
+            <a:ext cx="2286000" cy="1143000"/>
+          </a:xfrm>
+          <a:prstGeom prst="roundRect">
+            <a:avLst>
+              <a:gd name="adj" fmla="val 6400"/>
+            </a:avLst>
+          </a:prstGeom>
+          <a:solidFill>
+            <a:srgbClr val="21295C"/>
+          </a:solidFill>
+          <a:ln/>
+          <a:effectLst>
+            <a:outerShdw sx="100000" sy="100000" kx="0" ky="0" algn="bl" rotWithShape="0" blurRad="76200" dist="25400" dir="5400000">
+              <a:srgbClr val="9AA7B4">
+                <a:alpha val="35000"/>
+              </a:srgbClr>
+            </a:outerShdw>
+          </a:effectLst>
+        </p:spPr>
+      </p:sp>
+      <p:sp>
+        <p:nvSpPr>
+          <p:cNvPr id="4" name="Text 2"/>
+          <p:cNvSpPr txBox="1"/>
+          <p:nvPr/>
+        </p:nvSpPr>
+        <p:spPr>
+          <a:xfrm>
+            <a:off x="685800" y="1572768"/>
+            <a:ext cx="2011680" cy="914400"/>
+          </a:xfrm>
+          <a:prstGeom prst="rect">
+            <a:avLst/>
+          </a:prstGeom>
+          <a:noFill/>
+          <a:ln/>
+        </p:spPr>
+        <p:txBody>
+          <a:bodyPr wrap="square" rtlCol="0" anchor="t"/>
+          <a:lstStyle/>
+          <a:p>
+            <a:pPr algn="l" indent="0" marL="0">
+              <a:spcAft>
+                <a:spcPts val="400"/>
+              </a:spcAft>
+              <a:buNone/>
+            </a:pPr>
+            <a:r>
+              <a:rPr lang="en-US" sz="1400" b="1" dirty="0">
+                <a:solidFill>
+                  <a:srgbClr val="FFFFFF"/>
+                </a:solidFill>
+                <a:latin typeface="Calibri" pitchFamily="34" charset="0"/>
+                <a:ea typeface="Calibri" pitchFamily="34" charset="-122"/>
+                <a:cs typeface="Calibri" pitchFamily="34" charset="-120"/>
+              </a:rPr>
+              <a:t>samplesheet.csv</a:t>
+            </a:r>
+            <a:endParaRPr lang="en-US" sz="1400" dirty="0"/>
+          </a:p>
+          <a:p>
+            <a:pPr algn="l" indent="0" marL="0">
+              <a:buNone/>
+            </a:pPr>
+            <a:r>
+              <a:rPr lang="en-US" sz="1100" dirty="0">
+                <a:solidFill>
+                  <a:srgbClr val="DCEAF4"/>
+                </a:solidFill>
+                <a:latin typeface="Calibri" pitchFamily="34" charset="0"/>
+                <a:ea typeface="Calibri" pitchFamily="34" charset="-122"/>
+                <a:cs typeface="Calibri" pitchFamily="34" charset="-120"/>
+              </a:rPr>
+              <a:t>sample · datatype · bam / vcf</a:t>
+            </a:r>
+            <a:endParaRPr lang="en-US" sz="1400" dirty="0"/>
+          </a:p>
+        </p:txBody>
+      </p:sp>
+      <p:sp>
+        <p:nvSpPr>
+          <p:cNvPr id="5" name="stg-main.nf"/>
+          <p:cNvSpPr/>
+          <p:nvPr/>
+        </p:nvSpPr>
+        <p:spPr>
+          <a:xfrm>
+            <a:off x="3429000" y="1463040"/>
+            <a:ext cx="2286000" cy="1143000"/>
+          </a:xfrm>
+          <a:prstGeom prst="roundRect">
+            <a:avLst>
+              <a:gd name="adj" fmla="val 6400"/>
+            </a:avLst>
+          </a:prstGeom>
+          <a:solidFill>
+            <a:srgbClr val="EAF1F5"/>
+          </a:solidFill>
+          <a:ln/>
+          <a:effectLst>
+            <a:outerShdw sx="100000" sy="100000" kx="0" ky="0" algn="bl" rotWithShape="0" blurRad="76200" dist="25400" dir="5400000">
+              <a:srgbClr val="9AA7B4">
+                <a:alpha val="35000"/>
+              </a:srgbClr>
+            </a:outerShdw>
+          </a:effectLst>
+        </p:spPr>
+      </p:sp>
+      <p:sp>
+        <p:nvSpPr>
+          <p:cNvPr id="6" name="Text 4"/>
+          <p:cNvSpPr txBox="1"/>
+          <p:nvPr/>
+        </p:nvSpPr>
+        <p:spPr>
+          <a:xfrm>
+            <a:off x="3566160" y="1572768"/>
+            <a:ext cx="2011680" cy="914400"/>
+          </a:xfrm>
+          <a:prstGeom prst="rect">
+            <a:avLst/>
+          </a:prstGeom>
+          <a:noFill/>
+          <a:ln/>
+        </p:spPr>
+        <p:txBody>
+          <a:bodyPr wrap="square" rtlCol="0" anchor="t"/>
+          <a:lstStyle/>
+          <a:p>
+            <a:pPr algn="l" indent="0" marL="0">
+              <a:spcAft>
+                <a:spcPts val="400"/>
+              </a:spcAft>
+              <a:buNone/>
+            </a:pPr>
+            <a:r>
+              <a:rPr lang="en-US" sz="1400" b="1" dirty="0">
+                <a:solidFill>
+                  <a:srgbClr val="12243A"/>
+                </a:solidFill>
+                <a:latin typeface="Calibri" pitchFamily="34" charset="0"/>
+                <a:ea typeface="Calibri" pitchFamily="34" charset="-122"/>
+                <a:cs typeface="Calibri" pitchFamily="34" charset="-120"/>
+              </a:rPr>
+              <a:t>main.nf</a:t>
+            </a:r>
+            <a:endParaRPr lang="en-US" sz="1400" dirty="0"/>
+          </a:p>
+          <a:p>
+            <a:pPr algn="l" indent="0" marL="0">
+              <a:buNone/>
+            </a:pPr>
+            <a:r>
+              <a:rPr lang="en-US" sz="1100" dirty="0">
+                <a:solidFill>
+                  <a:srgbClr val="33475B"/>
+                </a:solidFill>
+                <a:latin typeface="Calibri" pitchFamily="34" charset="0"/>
+                <a:ea typeface="Calibri" pitchFamily="34" charset="-122"/>
+                <a:cs typeface="Calibri" pitchFamily="34" charset="-120"/>
+              </a:rPr>
+              <a:t>routes each row to channels by datatype</a:t>
+            </a:r>
+            <a:endParaRPr lang="en-US" sz="1400" dirty="0"/>
+          </a:p>
+        </p:txBody>
+      </p:sp>
+      <p:sp>
+        <p:nvSpPr>
+          <p:cNvPr id="7" name="stg-caller processes"/>
+          <p:cNvSpPr/>
+          <p:nvPr/>
+        </p:nvSpPr>
+        <p:spPr>
+          <a:xfrm>
+            <a:off x="6309360" y="1463040"/>
+            <a:ext cx="2286000" cy="1143000"/>
+          </a:xfrm>
+          <a:prstGeom prst="roundRect">
+            <a:avLst>
+              <a:gd name="adj" fmla="val 6400"/>
+            </a:avLst>
+          </a:prstGeom>
+          <a:solidFill>
+            <a:srgbClr val="065A82"/>
+          </a:solidFill>
+          <a:ln/>
+          <a:effectLst>
+            <a:outerShdw sx="100000" sy="100000" kx="0" ky="0" algn="bl" rotWithShape="0" blurRad="76200" dist="25400" dir="5400000">
+              <a:srgbClr val="9AA7B4">
+                <a:alpha val="35000"/>
+              </a:srgbClr>
+            </a:outerShdw>
+          </a:effectLst>
+        </p:spPr>
+      </p:sp>
+      <p:sp>
+        <p:nvSpPr>
+          <p:cNvPr id="8" name="Text 6"/>
+          <p:cNvSpPr txBox="1"/>
+          <p:nvPr/>
+        </p:nvSpPr>
+        <p:spPr>
+          <a:xfrm>
+            <a:off x="6446520" y="1572768"/>
+            <a:ext cx="2011680" cy="914400"/>
+          </a:xfrm>
+          <a:prstGeom prst="rect">
+            <a:avLst/>
+          </a:prstGeom>
+          <a:noFill/>
+          <a:ln/>
+        </p:spPr>
+        <p:txBody>
+          <a:bodyPr wrap="square" rtlCol="0" anchor="t"/>
+          <a:lstStyle/>
+          <a:p>
+            <a:pPr algn="l" indent="0" marL="0">
+              <a:spcAft>
+                <a:spcPts val="400"/>
+              </a:spcAft>
+              <a:buNone/>
+            </a:pPr>
+            <a:r>
+              <a:rPr lang="en-US" sz="1400" b="1" dirty="0">
+                <a:solidFill>
+                  <a:srgbClr val="FFFFFF"/>
+                </a:solidFill>
+                <a:latin typeface="Calibri" pitchFamily="34" charset="0"/>
+                <a:ea typeface="Calibri" pitchFamily="34" charset="-122"/>
+                <a:cs typeface="Calibri" pitchFamily="34" charset="-120"/>
+              </a:rPr>
+              <a:t>caller processes</a:t>
+            </a:r>
+            <a:endParaRPr lang="en-US" sz="1400" dirty="0"/>
+          </a:p>
+          <a:p>
+            <a:pPr algn="l" indent="0" marL="0">
+              <a:buNone/>
+            </a:pPr>
+            <a:r>
+              <a:rPr lang="en-US" sz="1100" dirty="0">
+                <a:solidFill>
+                  <a:srgbClr val="DCEAF4"/>
+                </a:solidFill>
+                <a:latin typeface="Calibri" pitchFamily="34" charset="0"/>
+                <a:ea typeface="Calibri" pitchFamily="34" charset="-122"/>
+                <a:cs typeface="Calibri" pitchFamily="34" charset="-120"/>
+              </a:rPr>
+              <a:t>one per tool, each in Singularity</a:t>
+            </a:r>
+            <a:endParaRPr lang="en-US" sz="1400" dirty="0"/>
+          </a:p>
+        </p:txBody>
+      </p:sp>
+      <p:sp>
+        <p:nvSpPr>
+          <p:cNvPr id="9" name="stg-post-processing"/>
+          <p:cNvSpPr/>
+          <p:nvPr/>
+        </p:nvSpPr>
+        <p:spPr>
+          <a:xfrm>
+            <a:off x="9189720" y="1463040"/>
+            <a:ext cx="2450592" cy="1143000"/>
+          </a:xfrm>
+          <a:prstGeom prst="roundRect">
+            <a:avLst>
+              <a:gd name="adj" fmla="val 6400"/>
+            </a:avLst>
+          </a:prstGeom>
+          <a:solidFill>
+            <a:srgbClr val="2E8B9E"/>
+          </a:solidFill>
+          <a:ln/>
+          <a:effectLst>
+            <a:outerShdw sx="100000" sy="100000" kx="0" ky="0" algn="bl" rotWithShape="0" blurRad="76200" dist="25400" dir="5400000">
+              <a:srgbClr val="9AA7B4">
+                <a:alpha val="35000"/>
+              </a:srgbClr>
+            </a:outerShdw>
+          </a:effectLst>
+        </p:spPr>
+      </p:sp>
+      <p:sp>
+        <p:nvSpPr>
+          <p:cNvPr id="10" name="Text 8"/>
+          <p:cNvSpPr txBox="1"/>
+          <p:nvPr/>
+        </p:nvSpPr>
+        <p:spPr>
+          <a:xfrm>
+            <a:off x="9326880" y="1572768"/>
+            <a:ext cx="2176272" cy="914400"/>
+          </a:xfrm>
+          <a:prstGeom prst="rect">
+            <a:avLst/>
+          </a:prstGeom>
+          <a:noFill/>
+          <a:ln/>
+        </p:spPr>
+        <p:txBody>
+          <a:bodyPr wrap="square" rtlCol="0" anchor="t"/>
+          <a:lstStyle/>
+          <a:p>
+            <a:pPr algn="l" indent="0" marL="0">
+              <a:spcAft>
+                <a:spcPts val="400"/>
+              </a:spcAft>
+              <a:buNone/>
+            </a:pPr>
+            <a:r>
+              <a:rPr lang="en-US" sz="1400" b="1" dirty="0">
+                <a:solidFill>
+                  <a:srgbClr val="FFFFFF"/>
+                </a:solidFill>
+                <a:latin typeface="Calibri" pitchFamily="34" charset="0"/>
+                <a:ea typeface="Calibri" pitchFamily="34" charset="-122"/>
+                <a:cs typeface="Calibri" pitchFamily="34" charset="-120"/>
+              </a:rPr>
+              <a:t>post-processing</a:t>
+            </a:r>
+            <a:endParaRPr lang="en-US" sz="1400" dirty="0"/>
+          </a:p>
+          <a:p>
+            <a:pPr algn="l" indent="0" marL="0">
+              <a:buNone/>
+            </a:pPr>
+            <a:r>
+              <a:rPr lang="en-US" sz="1100" dirty="0">
+                <a:solidFill>
+                  <a:srgbClr val="DCEAF4"/>
+                </a:solidFill>
+                <a:latin typeface="Calibri" pitchFamily="34" charset="0"/>
+                <a:ea typeface="Calibri" pitchFamily="34" charset="-122"/>
+                <a:cs typeface="Calibri" pitchFamily="34" charset="-120"/>
+              </a:rPr>
+              <a:t>parse → harmonize → consensus</a:t>
+            </a:r>
+            <a:endParaRPr lang="en-US" sz="1400" dirty="0"/>
+          </a:p>
+        </p:txBody>
+      </p:sp>
+      <p:sp>
+        <p:nvSpPr>
+          <p:cNvPr id="11" name="sa3.15"/>
+          <p:cNvSpPr/>
+          <p:nvPr/>
+        </p:nvSpPr>
+        <p:spPr>
+          <a:xfrm>
+            <a:off x="2880360" y="1828800"/>
+            <a:ext cx="438912" cy="411480"/>
+          </a:xfrm>
+          <a:prstGeom prst="rightArrow">
+            <a:avLst/>
+          </a:prstGeom>
+          <a:solidFill>
+            <a:srgbClr val="7C8B99"/>
+          </a:solidFill>
+          <a:ln/>
+        </p:spPr>
+      </p:sp>
+      <p:sp>
+        <p:nvSpPr>
+          <p:cNvPr id="12" name="sa6.3"/>
+          <p:cNvSpPr/>
+          <p:nvPr/>
+        </p:nvSpPr>
+        <p:spPr>
+          <a:xfrm>
+            <a:off x="5760720" y="1828800"/>
+            <a:ext cx="438912" cy="411480"/>
+          </a:xfrm>
+          <a:prstGeom prst="rightArrow">
+            <a:avLst/>
+          </a:prstGeom>
+          <a:solidFill>
+            <a:srgbClr val="7C8B99"/>
+          </a:solidFill>
+          <a:ln/>
+        </p:spPr>
+      </p:sp>
+      <p:sp>
+        <p:nvSpPr>
+          <p:cNvPr id="13" name="sa9.45"/>
+          <p:cNvSpPr/>
+          <p:nvPr/>
+        </p:nvSpPr>
+        <p:spPr>
+          <a:xfrm>
+            <a:off x="8641080" y="1828800"/>
+            <a:ext cx="438912" cy="411480"/>
+          </a:xfrm>
+          <a:prstGeom prst="rightArrow">
+            <a:avLst/>
+          </a:prstGeom>
+          <a:solidFill>
+            <a:srgbClr val="7C8B99"/>
+          </a:solidFill>
+          <a:ln/>
+        </p:spPr>
+      </p:sp>
+      <p:sp>
+        <p:nvSpPr>
+          <p:cNvPr id="14" name="Text 12"/>
+          <p:cNvSpPr txBox="1"/>
+          <p:nvPr/>
+        </p:nvSpPr>
+        <p:spPr>
+          <a:xfrm>
+            <a:off x="548640" y="2834640"/>
+            <a:ext cx="11064240" cy="365760"/>
+          </a:xfrm>
+          <a:prstGeom prst="rect">
+            <a:avLst/>
+          </a:prstGeom>
+          <a:noFill/>
+          <a:ln/>
+        </p:spPr>
+        <p:txBody>
+          <a:bodyPr wrap="square" rtlCol="0" anchor="ctr"/>
+          <a:lstStyle/>
+          <a:p>
+            <a:pPr algn="l" indent="0" marL="0">
+              <a:buNone/>
+            </a:pPr>
+            <a:r>
+              <a:rPr lang="en-US" sz="1250" dirty="0">
+                <a:solidFill>
+                  <a:srgbClr val="33475B"/>
+                </a:solidFill>
+                <a:latin typeface="Calibri" pitchFamily="34" charset="0"/>
+                <a:ea typeface="Calibri" pitchFamily="34" charset="-122"/>
+                <a:cs typeface="Calibri" pitchFamily="34" charset="-120"/>
+              </a:rPr>
+              <a:t>Each caller is its own Nextflow process in a pinned Singularity image — run, scaled and cached independently:</a:t>
+            </a:r>
+            <a:endParaRPr lang="en-US" sz="1250" dirty="0"/>
+          </a:p>
+        </p:txBody>
+      </p:sp>
+      <p:sp>
+        <p:nvSpPr>
+          <p:cNvPr id="15" name="chip-Stargazer"/>
+          <p:cNvSpPr/>
+          <p:nvPr/>
+        </p:nvSpPr>
+        <p:spPr>
+          <a:xfrm>
+            <a:off x="548640" y="3291840"/>
+            <a:ext cx="2468880" cy="512064"/>
+          </a:xfrm>
+          <a:prstGeom prst="roundRect">
+            <a:avLst>
+              <a:gd name="adj" fmla="val 10714"/>
+            </a:avLst>
+          </a:prstGeom>
+          <a:solidFill>
+            <a:srgbClr val="1C7293"/>
+          </a:solidFill>
+          <a:ln/>
+        </p:spPr>
+      </p:sp>
+      <p:sp>
+        <p:nvSpPr>
+          <p:cNvPr id="16" name="Text 14"/>
+          <p:cNvSpPr txBox="1"/>
+          <p:nvPr/>
+        </p:nvSpPr>
+        <p:spPr>
+          <a:xfrm>
+            <a:off x="548640" y="3291840"/>
+            <a:ext cx="2468880" cy="512064"/>
+          </a:xfrm>
+          <a:prstGeom prst="rect">
+            <a:avLst/>
+          </a:prstGeom>
+          <a:noFill/>
+          <a:ln/>
+        </p:spPr>
+        <p:txBody>
+          <a:bodyPr wrap="square" lIns="0" tIns="0" rIns="0" bIns="0" rtlCol="0" anchor="ctr"/>
+          <a:lstStyle/>
+          <a:p>
+            <a:pPr algn="ctr" indent="0" marL="0">
+              <a:buNone/>
+            </a:pPr>
+            <a:r>
+              <a:rPr lang="en-US" sz="1100" b="1" dirty="0">
+                <a:solidFill>
+                  <a:srgbClr val="FFFFFF"/>
+                </a:solidFill>
+                <a:latin typeface="Calibri" pitchFamily="34" charset="0"/>
+                <a:ea typeface="Calibri" pitchFamily="34" charset="-122"/>
+                <a:cs typeface="Calibri" pitchFamily="34" charset="-120"/>
+              </a:rPr>
+              <a:t>Stargazer</a:t>
+            </a:r>
+            <a:endParaRPr lang="en-US" sz="1100" dirty="0"/>
+          </a:p>
+        </p:txBody>
+      </p:sp>
+      <p:sp>
+        <p:nvSpPr>
+          <p:cNvPr id="17" name="chip-Cyrius"/>
+          <p:cNvSpPr/>
+          <p:nvPr/>
+        </p:nvSpPr>
+        <p:spPr>
+          <a:xfrm>
+            <a:off x="3364992" y="3291840"/>
+            <a:ext cx="2468880" cy="512064"/>
+          </a:xfrm>
+          <a:prstGeom prst="roundRect">
+            <a:avLst>
+              <a:gd name="adj" fmla="val 10714"/>
+            </a:avLst>
+          </a:prstGeom>
+          <a:solidFill>
+            <a:srgbClr val="065A82"/>
+          </a:solidFill>
+          <a:ln/>
+        </p:spPr>
+      </p:sp>
+      <p:sp>
+        <p:nvSpPr>
+          <p:cNvPr id="18" name="Text 16"/>
+          <p:cNvSpPr txBox="1"/>
+          <p:nvPr/>
+        </p:nvSpPr>
+        <p:spPr>
+          <a:xfrm>
+            <a:off x="3364992" y="3291840"/>
+            <a:ext cx="2468880" cy="512064"/>
+          </a:xfrm>
+          <a:prstGeom prst="rect">
+            <a:avLst/>
+          </a:prstGeom>
+          <a:noFill/>
+          <a:ln/>
+        </p:spPr>
+        <p:txBody>
+          <a:bodyPr wrap="square" lIns="0" tIns="0" rIns="0" bIns="0" rtlCol="0" anchor="ctr"/>
+          <a:lstStyle/>
+          <a:p>
+            <a:pPr algn="ctr" indent="0" marL="0">
+              <a:buNone/>
+            </a:pPr>
+            <a:r>
+              <a:rPr lang="en-US" sz="1100" b="1" dirty="0">
+                <a:solidFill>
+                  <a:srgbClr val="FFFFFF"/>
+                </a:solidFill>
+                <a:latin typeface="Calibri" pitchFamily="34" charset="0"/>
+                <a:ea typeface="Calibri" pitchFamily="34" charset="-122"/>
+                <a:cs typeface="Calibri" pitchFamily="34" charset="-120"/>
+              </a:rPr>
+              <a:t>Cyrius</a:t>
+            </a:r>
+            <a:endParaRPr lang="en-US" sz="1100" dirty="0"/>
+          </a:p>
+        </p:txBody>
+      </p:sp>
+      <p:sp>
+        <p:nvSpPr>
+          <p:cNvPr id="19" name="chip-PyPGx"/>
+          <p:cNvSpPr/>
+          <p:nvPr/>
+        </p:nvSpPr>
+        <p:spPr>
+          <a:xfrm>
+            <a:off x="6181344" y="3291840"/>
+            <a:ext cx="2468880" cy="512064"/>
+          </a:xfrm>
+          <a:prstGeom prst="roundRect">
+            <a:avLst>
+              <a:gd name="adj" fmla="val 10714"/>
+            </a:avLst>
+          </a:prstGeom>
+          <a:solidFill>
+            <a:srgbClr val="2E8B9E"/>
+          </a:solidFill>
+          <a:ln/>
+        </p:spPr>
+      </p:sp>
+      <p:sp>
+        <p:nvSpPr>
+          <p:cNvPr id="20" name="Text 18"/>
+          <p:cNvSpPr txBox="1"/>
+          <p:nvPr/>
+        </p:nvSpPr>
+        <p:spPr>
+          <a:xfrm>
+            <a:off x="6181344" y="3291840"/>
+            <a:ext cx="2468880" cy="512064"/>
+          </a:xfrm>
+          <a:prstGeom prst="rect">
+            <a:avLst/>
+          </a:prstGeom>
+          <a:noFill/>
+          <a:ln/>
+        </p:spPr>
+        <p:txBody>
+          <a:bodyPr wrap="square" lIns="0" tIns="0" rIns="0" bIns="0" rtlCol="0" anchor="ctr"/>
+          <a:lstStyle/>
+          <a:p>
+            <a:pPr algn="ctr" indent="0" marL="0">
+              <a:buNone/>
+            </a:pPr>
+            <a:r>
+              <a:rPr lang="en-US" sz="1100" b="1" dirty="0">
+                <a:solidFill>
+                  <a:srgbClr val="FFFFFF"/>
+                </a:solidFill>
+                <a:latin typeface="Calibri" pitchFamily="34" charset="0"/>
+                <a:ea typeface="Calibri" pitchFamily="34" charset="-122"/>
+                <a:cs typeface="Calibri" pitchFamily="34" charset="-120"/>
+              </a:rPr>
+              <a:t>PyPGx</a:t>
+            </a:r>
+            <a:endParaRPr lang="en-US" sz="1100" dirty="0"/>
+          </a:p>
+        </p:txBody>
+      </p:sp>
+      <p:sp>
+        <p:nvSpPr>
+          <p:cNvPr id="21" name="chip-Aldy"/>
+          <p:cNvSpPr/>
+          <p:nvPr/>
+        </p:nvSpPr>
+        <p:spPr>
+          <a:xfrm>
+            <a:off x="8997696" y="3291840"/>
+            <a:ext cx="2468880" cy="512064"/>
+          </a:xfrm>
+          <a:prstGeom prst="roundRect">
+            <a:avLst>
+              <a:gd name="adj" fmla="val 10714"/>
+            </a:avLst>
+          </a:prstGeom>
+          <a:solidFill>
+            <a:srgbClr val="3C4F76"/>
+          </a:solidFill>
+          <a:ln/>
+        </p:spPr>
+      </p:sp>
+      <p:sp>
+        <p:nvSpPr>
+          <p:cNvPr id="22" name="Text 20"/>
+          <p:cNvSpPr txBox="1"/>
+          <p:nvPr/>
+        </p:nvSpPr>
+        <p:spPr>
+          <a:xfrm>
+            <a:off x="8997696" y="3291840"/>
+            <a:ext cx="2468880" cy="512064"/>
+          </a:xfrm>
+          <a:prstGeom prst="rect">
+            <a:avLst/>
+          </a:prstGeom>
+          <a:noFill/>
+          <a:ln/>
+        </p:spPr>
+        <p:txBody>
+          <a:bodyPr wrap="square" lIns="0" tIns="0" rIns="0" bIns="0" rtlCol="0" anchor="ctr"/>
+          <a:lstStyle/>
+          <a:p>
+            <a:pPr algn="ctr" indent="0" marL="0">
+              <a:buNone/>
+            </a:pPr>
+            <a:r>
+              <a:rPr lang="en-US" sz="1100" b="1" dirty="0">
+                <a:solidFill>
+                  <a:srgbClr val="FFFFFF"/>
+                </a:solidFill>
+                <a:latin typeface="Calibri" pitchFamily="34" charset="0"/>
+                <a:ea typeface="Calibri" pitchFamily="34" charset="-122"/>
+                <a:cs typeface="Calibri" pitchFamily="34" charset="-120"/>
+              </a:rPr>
+              <a:t>Aldy</a:t>
+            </a:r>
+            <a:endParaRPr lang="en-US" sz="1100" dirty="0"/>
+          </a:p>
+        </p:txBody>
+      </p:sp>
+      <p:sp>
+        <p:nvSpPr>
+          <p:cNvPr id="23" name="ic-Repo layout"/>
+          <p:cNvSpPr/>
+          <p:nvPr/>
+        </p:nvSpPr>
+        <p:spPr>
+          <a:xfrm>
+            <a:off x="548640" y="4114800"/>
+            <a:ext cx="3529584" cy="1965960"/>
+          </a:xfrm>
+          <a:prstGeom prst="roundRect">
+            <a:avLst>
+              <a:gd name="adj" fmla="val 3721"/>
+            </a:avLst>
+          </a:prstGeom>
+          <a:solidFill>
+            <a:srgbClr val="EAF1F5"/>
+          </a:solidFill>
+          <a:ln w="12700">
+            <a:solidFill>
+              <a:srgbClr val="CBD6E0"/>
+            </a:solidFill>
+            <a:prstDash val="solid"/>
+          </a:ln>
+          <a:effectLst>
+            <a:outerShdw sx="100000" sy="100000" kx="0" ky="0" algn="bl" rotWithShape="0" blurRad="76200" dist="25400" dir="5400000">
+              <a:srgbClr val="9AA7B4">
+                <a:alpha val="35000"/>
+              </a:srgbClr>
+            </a:outerShdw>
+          </a:effectLst>
+        </p:spPr>
+      </p:sp>
+      <p:sp>
+        <p:nvSpPr>
+          <p:cNvPr id="24" name="Text 22"/>
+          <p:cNvSpPr txBox="1"/>
+          <p:nvPr/>
+        </p:nvSpPr>
+        <p:spPr>
+          <a:xfrm>
+            <a:off x="749808" y="4251960"/>
+            <a:ext cx="3127248" cy="365760"/>
+          </a:xfrm>
+          <a:prstGeom prst="rect">
+            <a:avLst/>
+          </a:prstGeom>
+          <a:noFill/>
+          <a:ln/>
+        </p:spPr>
+        <p:txBody>
+          <a:bodyPr wrap="square" rtlCol="0" anchor="ctr"/>
+          <a:lstStyle/>
+          <a:p>
+            <a:pPr algn="l" indent="0" marL="0">
+              <a:buNone/>
+            </a:pPr>
+            <a:r>
+              <a:rPr lang="en-US" sz="1400" b="1" dirty="0">
+                <a:solidFill>
+                  <a:srgbClr val="065A82"/>
+                </a:solidFill>
+                <a:latin typeface="Cambria" pitchFamily="34" charset="0"/>
+                <a:ea typeface="Cambria" pitchFamily="34" charset="-122"/>
+                <a:cs typeface="Cambria" pitchFamily="34" charset="-120"/>
+              </a:rPr>
+              <a:t>Repo layout</a:t>
+            </a:r>
+            <a:endParaRPr lang="en-US" sz="1400" dirty="0"/>
+          </a:p>
+        </p:txBody>
+      </p:sp>
+      <p:sp>
+        <p:nvSpPr>
+          <p:cNvPr id="25" name="Text 23"/>
+          <p:cNvSpPr txBox="1"/>
+          <p:nvPr/>
+        </p:nvSpPr>
+        <p:spPr>
+          <a:xfrm>
+            <a:off x="749808" y="4663440"/>
+            <a:ext cx="3163824" cy="1325880"/>
+          </a:xfrm>
+          <a:prstGeom prst="rect">
+            <a:avLst/>
+          </a:prstGeom>
+          <a:noFill/>
+          <a:ln/>
+        </p:spPr>
+        <p:txBody>
+          <a:bodyPr wrap="square" rtlCol="0" anchor="t"/>
+          <a:lstStyle/>
+          <a:p>
+            <a:pPr algn="l" marL="342900" indent="-342900">
+              <a:spcAft>
+                <a:spcPts val="500"/>
+              </a:spcAft>
+              <a:buSzPct val="100000"/>
+              <a:buChar char="•"/>
+            </a:pPr>
+            <a:r>
+              <a:rPr lang="en-US" sz="1150" dirty="0">
+                <a:solidFill>
+                  <a:srgbClr val="33475B"/>
+                </a:solidFill>
+                <a:latin typeface="Courier New" pitchFamily="34" charset="0"/>
+                <a:ea typeface="Courier New" pitchFamily="34" charset="-122"/>
+                <a:cs typeface="Courier New" pitchFamily="34" charset="-120"/>
+              </a:rPr>
+              <a:t>main.nf</a:t>
+            </a:r>
+            <a:endParaRPr lang="en-US" sz="1150" dirty="0"/>
+          </a:p>
+          <a:p>
+            <a:pPr algn="l" marL="342900" indent="-342900">
+              <a:spcAft>
+                <a:spcPts val="500"/>
+              </a:spcAft>
+              <a:buSzPct val="100000"/>
+              <a:buChar char="•"/>
+            </a:pPr>
+            <a:r>
+              <a:rPr lang="en-US" sz="1150" dirty="0">
+                <a:solidFill>
+                  <a:srgbClr val="33475B"/>
+                </a:solidFill>
+                <a:latin typeface="Courier New" pitchFamily="34" charset="0"/>
+                <a:ea typeface="Courier New" pitchFamily="34" charset="-122"/>
+                <a:cs typeface="Courier New" pitchFamily="34" charset="-120"/>
+              </a:rPr>
+              <a:t>modules/local/*.nf</a:t>
+            </a:r>
+            <a:endParaRPr lang="en-US" sz="1150" dirty="0"/>
+          </a:p>
+          <a:p>
+            <a:pPr algn="l" marL="342900" indent="-342900">
+              <a:spcAft>
+                <a:spcPts val="500"/>
+              </a:spcAft>
+              <a:buSzPct val="100000"/>
+              <a:buChar char="•"/>
+            </a:pPr>
+            <a:r>
+              <a:rPr lang="en-US" sz="1150" dirty="0">
+                <a:solidFill>
+                  <a:srgbClr val="33475B"/>
+                </a:solidFill>
+                <a:latin typeface="Courier New" pitchFamily="34" charset="0"/>
+                <a:ea typeface="Courier New" pitchFamily="34" charset="-122"/>
+                <a:cs typeface="Courier New" pitchFamily="34" charset="-120"/>
+              </a:rPr>
+              <a:t>bin/*.py</a:t>
+            </a:r>
+            <a:endParaRPr lang="en-US" sz="1150" dirty="0"/>
+          </a:p>
+          <a:p>
+            <a:pPr algn="l" marL="342900" indent="-342900">
+              <a:spcAft>
+                <a:spcPts val="500"/>
+              </a:spcAft>
+              <a:buSzPct val="100000"/>
+              <a:buChar char="•"/>
+            </a:pPr>
+            <a:r>
+              <a:rPr lang="en-US" sz="1150" dirty="0">
+                <a:solidFill>
+                  <a:srgbClr val="33475B"/>
+                </a:solidFill>
+                <a:latin typeface="Courier New" pitchFamily="34" charset="0"/>
+                <a:ea typeface="Courier New" pitchFamily="34" charset="-122"/>
+                <a:cs typeface="Courier New" pitchFamily="34" charset="-120"/>
+              </a:rPr>
+              <a:t>conf/ · assets/harmonization.tsv</a:t>
+            </a:r>
+            <a:endParaRPr lang="en-US" sz="1150" dirty="0"/>
+          </a:p>
+        </p:txBody>
+      </p:sp>
+      <p:sp>
+        <p:nvSpPr>
+          <p:cNvPr id="26" name="ic-Config &amp; profiles"/>
+          <p:cNvSpPr/>
+          <p:nvPr/>
+        </p:nvSpPr>
+        <p:spPr>
+          <a:xfrm>
+            <a:off x="4315968" y="4114800"/>
+            <a:ext cx="3529584" cy="1965960"/>
+          </a:xfrm>
+          <a:prstGeom prst="roundRect">
+            <a:avLst>
+              <a:gd name="adj" fmla="val 3721"/>
+            </a:avLst>
+          </a:prstGeom>
+          <a:solidFill>
+            <a:srgbClr val="EAF1F5"/>
+          </a:solidFill>
+          <a:ln w="12700">
+            <a:solidFill>
+              <a:srgbClr val="CBD6E0"/>
+            </a:solidFill>
+            <a:prstDash val="solid"/>
+          </a:ln>
+          <a:effectLst>
+            <a:outerShdw sx="100000" sy="100000" kx="0" ky="0" algn="bl" rotWithShape="0" blurRad="76200" dist="25400" dir="5400000">
+              <a:srgbClr val="9AA7B4">
+                <a:alpha val="35000"/>
+              </a:srgbClr>
+            </a:outerShdw>
+          </a:effectLst>
+        </p:spPr>
+      </p:sp>
+      <p:sp>
+        <p:nvSpPr>
+          <p:cNvPr id="27" name="Text 25"/>
+          <p:cNvSpPr txBox="1"/>
+          <p:nvPr/>
+        </p:nvSpPr>
+        <p:spPr>
+          <a:xfrm>
+            <a:off x="4517136" y="4251960"/>
+            <a:ext cx="3127248" cy="365760"/>
+          </a:xfrm>
+          <a:prstGeom prst="rect">
+            <a:avLst/>
+          </a:prstGeom>
+          <a:noFill/>
+          <a:ln/>
+        </p:spPr>
+        <p:txBody>
+          <a:bodyPr wrap="square" rtlCol="0" anchor="ctr"/>
+          <a:lstStyle/>
+          <a:p>
+            <a:pPr algn="l" indent="0" marL="0">
+              <a:buNone/>
+            </a:pPr>
+            <a:r>
+              <a:rPr lang="en-US" sz="1400" b="1" dirty="0">
+                <a:solidFill>
+                  <a:srgbClr val="2E8B9E"/>
+                </a:solidFill>
+                <a:latin typeface="Cambria" pitchFamily="34" charset="0"/>
+                <a:ea typeface="Cambria" pitchFamily="34" charset="-122"/>
+                <a:cs typeface="Cambria" pitchFamily="34" charset="-120"/>
+              </a:rPr>
+              <a:t>Config &amp; profiles</a:t>
+            </a:r>
+            <a:endParaRPr lang="en-US" sz="1400" dirty="0"/>
+          </a:p>
+        </p:txBody>
+      </p:sp>
+      <p:sp>
+        <p:nvSpPr>
+          <p:cNvPr id="28" name="Text 26"/>
+          <p:cNvSpPr txBox="1"/>
+          <p:nvPr/>
+        </p:nvSpPr>
+        <p:spPr>
+          <a:xfrm>
+            <a:off x="4517136" y="4663440"/>
+            <a:ext cx="3163824" cy="1325880"/>
+          </a:xfrm>
+          <a:prstGeom prst="rect">
+            <a:avLst/>
+          </a:prstGeom>
+          <a:noFill/>
+          <a:ln/>
+        </p:spPr>
+        <p:txBody>
+          <a:bodyPr wrap="square" rtlCol="0" anchor="t"/>
+          <a:lstStyle/>
+          <a:p>
+            <a:pPr algn="l" marL="342900" indent="-342900">
+              <a:spcAft>
+                <a:spcPts val="500"/>
+              </a:spcAft>
+              <a:buSzPct val="100000"/>
+              <a:buChar char="•"/>
+            </a:pPr>
+            <a:r>
+              <a:rPr lang="en-US" sz="1150" dirty="0">
+                <a:solidFill>
+                  <a:srgbClr val="33475B"/>
+                </a:solidFill>
+                <a:latin typeface="Courier New" pitchFamily="34" charset="0"/>
+                <a:ea typeface="Courier New" pitchFamily="34" charset="-122"/>
+                <a:cs typeface="Courier New" pitchFamily="34" charset="-120"/>
+              </a:rPr>
+              <a:t>-profile singularity , slurm , test</a:t>
+            </a:r>
+            <a:endParaRPr lang="en-US" sz="1150" dirty="0"/>
+          </a:p>
+          <a:p>
+            <a:pPr algn="l" marL="342900" indent="-342900">
+              <a:spcAft>
+                <a:spcPts val="500"/>
+              </a:spcAft>
+              <a:buSzPct val="100000"/>
+              <a:buChar char="•"/>
+            </a:pPr>
+            <a:r>
+              <a:rPr lang="en-US" sz="1150" dirty="0">
+                <a:solidFill>
+                  <a:srgbClr val="33475B"/>
+                </a:solidFill>
+                <a:latin typeface="Courier New" pitchFamily="34" charset="0"/>
+                <a:ea typeface="Courier New" pitchFamily="34" charset="-122"/>
+                <a:cs typeface="Courier New" pitchFamily="34" charset="-120"/>
+              </a:rPr>
+              <a:t>--genome_build GRCh37 | GRCh38</a:t>
+            </a:r>
+            <a:endParaRPr lang="en-US" sz="1150" dirty="0"/>
+          </a:p>
+          <a:p>
+            <a:pPr algn="l" marL="342900" indent="-342900">
+              <a:spcAft>
+                <a:spcPts val="500"/>
+              </a:spcAft>
+              <a:buSzPct val="100000"/>
+              <a:buChar char="•"/>
+            </a:pPr>
+            <a:r>
+              <a:rPr lang="en-US" sz="1150" dirty="0">
+                <a:solidFill>
+                  <a:srgbClr val="33475B"/>
+                </a:solidFill>
+                <a:latin typeface="Courier New" pitchFamily="34" charset="0"/>
+                <a:ea typeface="Courier New" pitchFamily="34" charset="-122"/>
+                <a:cs typeface="Courier New" pitchFamily="34" charset="-120"/>
+              </a:rPr>
+              <a:t>--fasta  ·  --run_&lt;tool&gt;</a:t>
+            </a:r>
+            <a:endParaRPr lang="en-US" sz="1150" dirty="0"/>
+          </a:p>
+        </p:txBody>
+      </p:sp>
+      <p:sp>
+        <p:nvSpPr>
+          <p:cNvPr id="29" name="ic-Reproducible by design"/>
+          <p:cNvSpPr/>
+          <p:nvPr/>
+        </p:nvSpPr>
+        <p:spPr>
+          <a:xfrm>
+            <a:off x="8083296" y="4114800"/>
+            <a:ext cx="3529584" cy="1965960"/>
+          </a:xfrm>
+          <a:prstGeom prst="roundRect">
+            <a:avLst>
+              <a:gd name="adj" fmla="val 3721"/>
+            </a:avLst>
+          </a:prstGeom>
+          <a:solidFill>
+            <a:srgbClr val="EAF1F5"/>
+          </a:solidFill>
+          <a:ln w="12700">
+            <a:solidFill>
+              <a:srgbClr val="CBD6E0"/>
+            </a:solidFill>
+            <a:prstDash val="solid"/>
+          </a:ln>
+          <a:effectLst>
+            <a:outerShdw sx="100000" sy="100000" kx="0" ky="0" algn="bl" rotWithShape="0" blurRad="76200" dist="25400" dir="5400000">
+              <a:srgbClr val="9AA7B4">
+                <a:alpha val="35000"/>
+              </a:srgbClr>
+            </a:outerShdw>
+          </a:effectLst>
+        </p:spPr>
+      </p:sp>
+      <p:sp>
+        <p:nvSpPr>
+          <p:cNvPr id="30" name="Text 28"/>
+          <p:cNvSpPr txBox="1"/>
+          <p:nvPr/>
+        </p:nvSpPr>
+        <p:spPr>
+          <a:xfrm>
+            <a:off x="8284464" y="4251960"/>
+            <a:ext cx="3127248" cy="365760"/>
+          </a:xfrm>
+          <a:prstGeom prst="rect">
+            <a:avLst/>
+          </a:prstGeom>
+          <a:noFill/>
+          <a:ln/>
+        </p:spPr>
+        <p:txBody>
+          <a:bodyPr wrap="square" rtlCol="0" anchor="ctr"/>
+          <a:lstStyle/>
+          <a:p>
+            <a:pPr algn="l" indent="0" marL="0">
+              <a:buNone/>
+            </a:pPr>
+            <a:r>
+              <a:rPr lang="en-US" sz="1400" b="1" dirty="0">
+                <a:solidFill>
+                  <a:srgbClr val="3C4F76"/>
+                </a:solidFill>
+                <a:latin typeface="Cambria" pitchFamily="34" charset="0"/>
+                <a:ea typeface="Cambria" pitchFamily="34" charset="-122"/>
+                <a:cs typeface="Cambria" pitchFamily="34" charset="-120"/>
+              </a:rPr>
+              <a:t>Reproducible by design</a:t>
+            </a:r>
+            <a:endParaRPr lang="en-US" sz="1400" dirty="0"/>
+          </a:p>
+        </p:txBody>
+      </p:sp>
+      <p:sp>
+        <p:nvSpPr>
+          <p:cNvPr id="31" name="Text 29"/>
+          <p:cNvSpPr txBox="1"/>
+          <p:nvPr/>
+        </p:nvSpPr>
+        <p:spPr>
+          <a:xfrm>
+            <a:off x="8284464" y="4663440"/>
+            <a:ext cx="3163824" cy="1325880"/>
+          </a:xfrm>
+          <a:prstGeom prst="rect">
+            <a:avLst/>
+          </a:prstGeom>
+          <a:noFill/>
+          <a:ln/>
+        </p:spPr>
+        <p:txBody>
+          <a:bodyPr wrap="square" rtlCol="0" anchor="t"/>
+          <a:lstStyle/>
+          <a:p>
+            <a:pPr algn="l" marL="342900" indent="-342900">
+              <a:spcAft>
+                <a:spcPts val="500"/>
+              </a:spcAft>
+              <a:buSzPct val="100000"/>
+              <a:buChar char="•"/>
+            </a:pPr>
+            <a:r>
+              <a:rPr lang="en-US" sz="1150" dirty="0">
+                <a:solidFill>
+                  <a:srgbClr val="33475B"/>
+                </a:solidFill>
+                <a:latin typeface="Calibri" pitchFamily="34" charset="0"/>
+                <a:ea typeface="Calibri" pitchFamily="34" charset="-122"/>
+                <a:cs typeface="Calibri" pitchFamily="34" charset="-120"/>
+              </a:rPr>
+              <a:t>pinned container image per tool</a:t>
+            </a:r>
+            <a:endParaRPr lang="en-US" sz="1150" dirty="0"/>
+          </a:p>
+          <a:p>
+            <a:pPr algn="l" marL="342900" indent="-342900">
+              <a:spcAft>
+                <a:spcPts val="500"/>
+              </a:spcAft>
+              <a:buSzPct val="100000"/>
+              <a:buChar char="•"/>
+            </a:pPr>
+            <a:r>
+              <a:rPr lang="en-US" sz="1150" dirty="0">
+                <a:solidFill>
+                  <a:srgbClr val="33475B"/>
+                </a:solidFill>
+                <a:latin typeface="Courier New" pitchFamily="34" charset="0"/>
+                <a:ea typeface="Courier New" pitchFamily="34" charset="-122"/>
+                <a:cs typeface="Courier New" pitchFamily="34" charset="-120"/>
+              </a:rPr>
+              <a:t>-resume  caches finished steps</a:t>
+            </a:r>
+            <a:endParaRPr lang="en-US" sz="1150" dirty="0"/>
+          </a:p>
+          <a:p>
+            <a:pPr algn="l" marL="342900" indent="-342900">
+              <a:spcAft>
+                <a:spcPts val="500"/>
+              </a:spcAft>
+              <a:buSzPct val="100000"/>
+              <a:buChar char="•"/>
+            </a:pPr>
+            <a:r>
+              <a:rPr lang="en-US" sz="1150" dirty="0">
+                <a:solidFill>
+                  <a:srgbClr val="33475B"/>
+                </a:solidFill>
+                <a:latin typeface="Courier New" pitchFamily="34" charset="0"/>
+                <a:ea typeface="Courier New" pitchFamily="34" charset="-122"/>
+                <a:cs typeface="Courier New" pitchFamily="34" charset="-120"/>
+              </a:rPr>
+              <a:t>-stub  dry-runs the whole graph</a:t>
+            </a:r>
+            <a:endParaRPr lang="en-US" sz="1150" dirty="0"/>
+          </a:p>
+          <a:p>
+            <a:pPr algn="l" marL="342900" indent="-342900">
+              <a:spcAft>
+                <a:spcPts val="500"/>
+              </a:spcAft>
+              <a:buSzPct val="100000"/>
+              <a:buChar char="•"/>
+            </a:pPr>
+            <a:r>
+              <a:rPr lang="en-US" sz="1150" dirty="0">
+                <a:solidFill>
+                  <a:srgbClr val="33475B"/>
+                </a:solidFill>
+                <a:latin typeface="Calibri" pitchFamily="34" charset="0"/>
+                <a:ea typeface="Calibri" pitchFamily="34" charset="-122"/>
+                <a:cs typeface="Calibri" pitchFamily="34" charset="-120"/>
+              </a:rPr>
+              <a:t>per-process cpus / memory / time</a:t>
+            </a:r>
+            <a:endParaRPr lang="en-US" sz="1150" dirty="0"/>
+          </a:p>
+        </p:txBody>
+      </p:sp>
+      <p:sp>
+        <p:nvSpPr>
+          <p:cNvPr id="25" name="Slide Number Placeholder 0"/>
+          <p:cNvSpPr>
+            <a:spLocks noGrp="1"/>
+          </p:cNvSpPr>
+          <p:nvPr>
+            <p:ph type="sldNum" sz="quarter" idx="4294967295"/>
+          </p:nvPr>
+        </p:nvSpPr>
+        <p:spPr>
+          <a:xfrm>
+            <a:off x="11430000" y="6428232"/>
+            <a:ext cx="548640" cy="274320"/>
+          </a:xfrm>
+          <a:prstGeom prst="rect">
+            <a:avLst/>
+          </a:prstGeom>
+          <a:extLst>
+            <a:ext uri="{C572A759-6A51-4108-AA02-DFA0A04FC94B}">
+              <ma14:wrappingTextBoxFlag xmlns:ma14="http://schemas.microsoft.com/office/mac/drawingml/2011/main" val="0"/>
+            </a:ext>
+          </a:extLst>
+        </p:spPr>
+        <p:txBody>
+          <a:bodyPr/>
+          <a:lstStyle>
+            <a:lvl1pPr>
+              <a:defRPr sz="900">
+                <a:solidFill>
+                  <a:srgbClr val="7C8B99"/>
+                </a:solidFill>
+              </a:defRPr>
+            </a:lvl1pPr>
+          </a:lstStyle>
+          <a:p>
+            <a:pPr algn="r"/>
+            <a:fld id="{F7021451-1387-4CA6-816F-3879F97B5CBC}" type="slidenum">
+              <a:rPr b="0" lang="en-US"/>
+              <a:t>10</a:t>
+            </a:fld>
+            <a:endParaRPr lang="en-US"/>
+          </a:p>
+        </p:txBody>
+      </p:sp>
+    </p:spTree>
+  </p:cSld>
+  <p:clrMapOvr>
+    <a:masterClrMapping/>
+  </p:clrMapOvr>
+</p:sld>
+</file>
+
+<file path=ppt/slides/slide11.xml><?xml version="1.0" encoding="utf-8"?>
+<p:sld xmlns:a="http://schemas.openxmlformats.org/drawingml/2006/main" xmlns:r="http://schemas.openxmlformats.org/officeDocument/2006/relationships" xmlns:p="http://schemas.openxmlformats.org/presentationml/2006/main">
+  <p:cSld name="Slide 11">
     <p:spTree>
       <p:nvGrpSpPr>
         <p:cNvPr id="1" name=""/>

</xml_diff>